<commit_message>
Week 14 Part 5: cover slide details + correction-log slide reselection
Per user request:
- Cover slide now shows the course/class label (115年Python程式設計與AI
  應用-第二期), "期末專題", and the author's name/student number
  (黃家輝 學號09) above/below the title, not just a bare title+date.
- Correction-log slide (10) now picks weeks 5/6/8 instead of 6/8/10,
  each annotated by its OWN discovery mode rather than a generic
  description: week 5 (found by checking time alignment after seeing an
  anomalous result, p=0.001->0.85 - verified against week05_review_
  notes.md's own table before using it), week 6 (found by a test, before
  looking at any result), week 8 (found by an additional significance
  check the original success criteria didn't include). Footer changed to
  "完整六條見報告附錄".

Re-verified both changed slides in the LibreOffice-rendered PDF: no
overflow, arrow character renders correctly, table still fits within
the page.

Co-Authored-By: Claude Sonnet 5 <noreply@anthropic.com>
</commit_message>
<xml_diff>
--- a/qqq-ml/reports/defense_slides.pptx
+++ b/qqq-ml/reports/defense_slides.pptx
@@ -591,7 +591,7 @@
               <a:rPr sz="1200">
                 <a:latin typeface="Noto Sans TC"/>
               </a:rPr>
-              <a:t>只挑3條最能展示『紀律有實際作用』的,不是列滿6條。強調第6週那條是主動發現、不是被結果異常倒逼。對應問答:第6題。</a:t>
+              <a:t>三條分別代表三種發現方式:事後查時間對齊(週5)、寫測試主動抓到(週6)、追加檢定才發現標準不夠嚴格(週8)——不是同一種模式重複三次。對應問答:第6題。</a:t>
             </a:r>
           </a:p>
         </p:txBody>
@@ -4489,7 +4489,52 @@
         </p:nvSpPr>
         <p:spPr>
           <a:xfrm>
-            <a:off x="914400" y="2194560"/>
+            <a:off x="914400" y="1051560"/>
+            <a:ext cx="10332720" cy="822960"/>
+          </a:xfrm>
+          <a:prstGeom prst="rect">
+            <a:avLst/>
+          </a:prstGeom>
+          <a:noFill/>
+        </p:spPr>
+        <p:txBody>
+          <a:bodyPr wrap="square">
+            <a:spAutoFit/>
+          </a:bodyPr>
+          <a:lstStyle/>
+          <a:p>
+            <a:r>
+              <a:rPr sz="1800">
+                <a:solidFill>
+                  <a:srgbClr val="52514E"/>
+                </a:solidFill>
+                <a:latin typeface="Noto Sans TC"/>
+              </a:rPr>
+              <a:t>115年Python程式設計與AI應用-第二期</a:t>
+            </a:r>
+          </a:p>
+          <a:p>
+            <a:r>
+              <a:rPr sz="1800">
+                <a:solidFill>
+                  <a:srgbClr val="8A8984"/>
+                </a:solidFill>
+                <a:latin typeface="Noto Sans TC"/>
+              </a:rPr>
+              <a:t>期末專題</a:t>
+            </a:r>
+          </a:p>
+        </p:txBody>
+      </p:sp>
+      <p:sp>
+        <p:nvSpPr>
+          <p:cNvPr id="3" name="TextBox 2"/>
+          <p:cNvSpPr txBox="1"/>
+          <p:nvPr/>
+        </p:nvSpPr>
+        <p:spPr>
+          <a:xfrm>
+            <a:off x="914400" y="2331720"/>
             <a:ext cx="10332720" cy="1463040"/>
           </a:xfrm>
           <a:prstGeom prst="rect">
@@ -4528,7 +4573,7 @@
       </p:sp>
       <p:sp>
         <p:nvSpPr>
-          <p:cNvPr id="3" name="TextBox 2"/>
+          <p:cNvPr id="4" name="TextBox 3"/>
           <p:cNvSpPr txBox="1"/>
           <p:nvPr/>
         </p:nvSpPr>
@@ -4555,7 +4600,7 @@
                 </a:solidFill>
                 <a:latin typeface="Noto Sans TC"/>
               </a:rPr>
-              <a:t>gre888</a:t>
+              <a:t>黃家輝  學號09</a:t>
             </a:r>
           </a:p>
           <a:p>
@@ -4573,7 +4618,7 @@
       </p:sp>
       <p:sp>
         <p:nvSpPr>
-          <p:cNvPr id="4" name="TextBox 3"/>
+          <p:cNvPr id="5" name="TextBox 4"/>
           <p:cNvSpPr txBox="1"/>
           <p:nvPr/>
         </p:nvSpPr>
@@ -4748,13 +4793,81 @@
                           </a:solidFill>
                           <a:latin typeface="Noto Sans TC"/>
                         </a:rPr>
-                        <a:t>怎麼發現的</a:t>
+                        <a:t>發現方式</a:t>
                       </a:r>
                     </a:p>
                   </a:txBody>
                   <a:tcPr>
                     <a:solidFill>
                       <a:srgbClr val="2A78D6"/>
+                    </a:solidFill>
+                  </a:tcPr>
+                </a:tc>
+              </a:tr>
+              <a:tr h="594360">
+                <a:tc>
+                  <a:txBody>
+                    <a:bodyPr/>
+                    <a:lstStyle/>
+                    <a:p>
+                      <a:r>
+                        <a:rPr sz="1600">
+                          <a:solidFill>
+                            <a:srgbClr val="0B0B0B"/>
+                          </a:solidFill>
+                          <a:latin typeface="Noto Sans TC"/>
+                        </a:rPr>
+                        <a:t>5</a:t>
+                      </a:r>
+                    </a:p>
+                  </a:txBody>
+                  <a:tcPr>
+                    <a:solidFill>
+                      <a:srgbClr val="FCFCFB"/>
+                    </a:solidFill>
+                  </a:tcPr>
+                </a:tc>
+                <a:tc>
+                  <a:txBody>
+                    <a:bodyPr/>
+                    <a:lstStyle/>
+                    <a:p>
+                      <a:r>
+                        <a:rPr sz="1600">
+                          <a:solidFill>
+                            <a:srgbClr val="0B0B0B"/>
+                          </a:solidFill>
+                          <a:latin typeface="Noto Sans TC"/>
+                        </a:rPr>
+                        <a:t>20日歷史波動前視偏誤</a:t>
+                      </a:r>
+                    </a:p>
+                  </a:txBody>
+                  <a:tcPr>
+                    <a:solidFill>
+                      <a:srgbClr val="FCFCFB"/>
+                    </a:solidFill>
+                  </a:tcPr>
+                </a:tc>
+                <a:tc>
+                  <a:txBody>
+                    <a:bodyPr/>
+                    <a:lstStyle/>
+                    <a:p>
+                      <a:r>
+                        <a:rPr sz="1600">
+                          <a:solidFill>
+                            <a:srgbClr val="0B0B0B"/>
+                          </a:solidFill>
+                          <a:latin typeface="Noto Sans TC"/>
+                        </a:rPr>
+                        <a:t>看到異常結果後查時間對齊(p=0.001→0.85)</a:t>
+                      </a:r>
+                    </a:p>
+                  </a:txBody>
+                  <a:tcPr>
+                    <a:solidFill>
+                      <a:srgbClr val="FCFCFB"/>
                     </a:solidFill>
                   </a:tcPr>
                 </a:tc>
@@ -4794,7 +4907,7 @@
                           </a:solidFill>
                           <a:latin typeface="Noto Sans TC"/>
                         </a:rPr>
-                        <a:t>HMM樣本外解碼漏轉移步驟</a:t>
+                        <a:t>HMM濾波漏轉移</a:t>
                       </a:r>
                     </a:p>
                   </a:txBody>
@@ -4816,7 +4929,7 @@
                           </a:solidFill>
                           <a:latin typeface="Noto Sans TC"/>
                         </a:rPr>
-                        <a:t>寫測試時主動發現,看任何結果前就修正</a:t>
+                        <a:t>看結果前由測試抓到</a:t>
                       </a:r>
                     </a:p>
                   </a:txBody>
@@ -4862,7 +4975,7 @@
                           </a:solidFill>
                           <a:latin typeface="Noto Sans TC"/>
                         </a:rPr>
-                        <a:t>三項成功標準字面上全過</a:t>
+                        <a:t>成功標準不足</a:t>
                       </a:r>
                     </a:p>
                   </a:txBody>
@@ -4884,75 +4997,7 @@
                           </a:solidFill>
                           <a:latin typeface="Noto Sans TC"/>
                         </a:rPr>
-                        <a:t>使用者要求補四項檢查後,推翻字面結論</a:t>
-                      </a:r>
-                    </a:p>
-                  </a:txBody>
-                  <a:tcPr>
-                    <a:solidFill>
-                      <a:srgbClr val="FCFCFB"/>
-                    </a:solidFill>
-                  </a:tcPr>
-                </a:tc>
-              </a:tr>
-              <a:tr h="594360">
-                <a:tc>
-                  <a:txBody>
-                    <a:bodyPr/>
-                    <a:lstStyle/>
-                    <a:p>
-                      <a:r>
-                        <a:rPr sz="1600">
-                          <a:solidFill>
-                            <a:srgbClr val="0B0B0B"/>
-                          </a:solidFill>
-                          <a:latin typeface="Noto Sans TC"/>
-                        </a:rPr>
-                        <a:t>10</a:t>
-                      </a:r>
-                    </a:p>
-                  </a:txBody>
-                  <a:tcPr>
-                    <a:solidFill>
-                      <a:srgbClr val="FCFCFB"/>
-                    </a:solidFill>
-                  </a:tcPr>
-                </a:tc>
-                <a:tc>
-                  <a:txBody>
-                    <a:bodyPr/>
-                    <a:lstStyle/>
-                    <a:p>
-                      <a:r>
-                        <a:rPr sz="1600">
-                          <a:solidFill>
-                            <a:srgbClr val="0B0B0B"/>
-                          </a:solidFill>
-                          <a:latin typeface="Noto Sans TC"/>
-                        </a:rPr>
-                        <a:t>排序層p值換種子會跳動</a:t>
-                      </a:r>
-                    </a:p>
-                  </a:txBody>
-                  <a:tcPr>
-                    <a:solidFill>
-                      <a:srgbClr val="FCFCFB"/>
-                    </a:solidFill>
-                  </a:tcPr>
-                </a:tc>
-                <a:tc>
-                  <a:txBody>
-                    <a:bodyPr/>
-                    <a:lstStyle/>
-                    <a:p>
-                      <a:r>
-                        <a:rPr sz="1600">
-                          <a:solidFill>
-                            <a:srgbClr val="0B0B0B"/>
-                          </a:solidFill>
-                          <a:latin typeface="Noto Sans TC"/>
-                        </a:rPr>
-                        <a:t>查出是蒙地卡羅精度不足,不是真的不穩健</a:t>
+                        <a:t>追加檢定發現原標準不夠嚴格</a:t>
                       </a:r>
                     </a:p>
                   </a:txBody>
@@ -5004,7 +5049,7 @@
                 </a:solidFill>
                 <a:latin typeface="Noto Sans TC"/>
               </a:rPr>
-              <a:t>•  完整6條記錄在附錄A,每條都寫發現方式、影響範圍、修正後結論</a:t>
+              <a:t>•  完整六條見報告附錄</a:t>
             </a:r>
           </a:p>
         </p:txBody>

</xml_diff>